<commit_message>
Used old time version
</commit_message>
<xml_diff>
--- a/results/Making a Presentation Presentation Spanish.pptx
+++ b/results/Making a Presentation Presentation Spanish.pptx
@@ -13939,8 +13939,12 @@
           <a:lstStyle/>
           <a:p>
             <a:r>
-              <a:t>¿Cuáles son los diferentes tipos de presentaciones?</a:t>
-            </a:r>
+              <a:rPr lang="en-US" dirty="0">
+                <a:cs typeface="Calibri Light"/>
+              </a:rPr>
+              <a:t>What are different types of presentations?</a:t>
+            </a:r>
+            <a:endParaRPr lang="en-US" dirty="0"/>
           </a:p>
         </p:txBody>
       </p:sp>
@@ -13968,27 +13972,42 @@
           <a:lstStyle/>
           <a:p>
             <a:r>
-              <a:t>Informativo</a:t>
-            </a:r>
-          </a:p>
-          <a:p>
-            <a:r>
-              <a:t>instructivo</a:t>
-            </a:r>
-          </a:p>
-          <a:p>
-            <a:r>
-              <a:t>persuasivo</a:t>
-            </a:r>
-          </a:p>
-          <a:p>
-            <a:r>
-              <a:t>Toma de decisiones</a:t>
-            </a:r>
-          </a:p>
-          <a:p>
-            <a:r>
-              <a:t>Progreso</a:t>
+              <a:rPr lang="en-US" dirty="0">
+                <a:cs typeface="Calibri"/>
+              </a:rPr>
+              <a:t>Informative</a:t>
+            </a:r>
+          </a:p>
+          <a:p>
+            <a:r>
+              <a:rPr lang="en-US" dirty="0">
+                <a:cs typeface="Calibri"/>
+              </a:rPr>
+              <a:t>Instructive</a:t>
+            </a:r>
+          </a:p>
+          <a:p>
+            <a:r>
+              <a:rPr lang="en-US" dirty="0">
+                <a:cs typeface="Calibri"/>
+              </a:rPr>
+              <a:t>Persuasive</a:t>
+            </a:r>
+          </a:p>
+          <a:p>
+            <a:r>
+              <a:rPr lang="en-US" dirty="0">
+                <a:cs typeface="Calibri"/>
+              </a:rPr>
+              <a:t>Decision Making</a:t>
+            </a:r>
+          </a:p>
+          <a:p>
+            <a:r>
+              <a:rPr lang="en-US" dirty="0">
+                <a:cs typeface="Calibri"/>
+              </a:rPr>
+              <a:t>Progress</a:t>
             </a:r>
           </a:p>
         </p:txBody>
@@ -14016,8 +14035,14 @@
           </a:bodyPr>
           <a:lstStyle/>
           <a:p>
-            <a:r>
-              <a:t>Imagen</a:t>
+            <a:pPr marL="0" indent="0">
+              <a:buNone/>
+            </a:pPr>
+            <a:r>
+              <a:rPr lang="en-US" dirty="0">
+                <a:cs typeface="Calibri"/>
+              </a:rPr>
+              <a:t>Picture</a:t>
             </a:r>
           </a:p>
         </p:txBody>
@@ -14086,7 +14111,9 @@
             <a:spAutoFit/>
           </a:bodyPr>
           <a:lstStyle/>
-          <a:p/>
+          <a:p>
+            <a:endParaRPr lang="en-US"/>
+          </a:p>
         </p:txBody>
       </p:sp>
       <p:pic>
@@ -14188,7 +14215,10 @@
           <a:lstStyle/>
           <a:p>
             <a:r>
-              <a:t>Presentación Buenos/Malos Ejemplos</a:t>
+              <a:rPr lang="en-US" dirty="0">
+                <a:cs typeface="Calibri Light"/>
+              </a:rPr>
+              <a:t>Presentation Good/Bad Examples</a:t>
             </a:r>
           </a:p>
         </p:txBody>
@@ -14216,9 +14246,16 @@
           </a:bodyPr>
           <a:lstStyle/>
           <a:p>
-            <a:r>
+            <a:pPr marL="0" lvl="0" indent="0">
+              <a:buNone/>
+            </a:pPr>
+            <a:r>
+              <a:rPr lang="en-US" b="1" u="sng" dirty="0">
+                <a:hlinkClick r:id="rId3"/>
+              </a:rPr>
               <a:t>https://youtu.be/S5c1susCPAE</a:t>
             </a:r>
+            <a:endParaRPr lang="en-US" b="1" dirty="0"/>
           </a:p>
         </p:txBody>
       </p:sp>
@@ -14443,7 +14480,8 @@
           <a:lstStyle/>
           <a:p>
             <a:r>
-              <a:t>¿Cuáles son algunas cosas que se deben evitar en una presentación?</a:t>
+              <a:rPr lang="en-US" dirty="0"/>
+              <a:t>What are some things to avoid in a presentation?</a:t>
             </a:r>
           </a:p>
         </p:txBody>
@@ -14476,28 +14514,38 @@
           </a:bodyPr>
           <a:lstStyle/>
           <a:p>
-            <a:r>
-              <a:t>Olvidándose del público. </a:t>
-            </a:r>
-          </a:p>
-          <a:p>
-            <a:r>
-              <a:t>Palabra por palabra</a:t>
-            </a:r>
-          </a:p>
-          <a:p>
-            <a:r>
-              <a:t>Presentación demasiado ocupada</a:t>
-            </a:r>
-          </a:p>
-          <a:p>
-            <a:r>
-              <a:t>Presentar sin practicar</a:t>
-            </a:r>
-          </a:p>
-          <a:p>
-            <a:r>
-              <a:t> Entrar en pánico por las sorpresas</a:t>
+            <a:pPr lvl="0" fontAlgn="base"/>
+            <a:r>
+              <a:rPr lang="en-US" dirty="0"/>
+              <a:t>Forgetting about the audience. </a:t>
+            </a:r>
+          </a:p>
+          <a:p>
+            <a:pPr lvl="0" fontAlgn="base"/>
+            <a:r>
+              <a:rPr lang="en-US" dirty="0"/>
+              <a:t>Word for word</a:t>
+            </a:r>
+          </a:p>
+          <a:p>
+            <a:pPr lvl="0" fontAlgn="base"/>
+            <a:r>
+              <a:rPr lang="en-US" dirty="0"/>
+              <a:t>Too busy presentation</a:t>
+            </a:r>
+          </a:p>
+          <a:p>
+            <a:pPr lvl="0" fontAlgn="base"/>
+            <a:r>
+              <a:rPr lang="en-US" dirty="0"/>
+              <a:t>Presenting without practicing</a:t>
+            </a:r>
+          </a:p>
+          <a:p>
+            <a:pPr lvl="0" fontAlgn="base"/>
+            <a:r>
+              <a:rPr lang="en-US" dirty="0"/>
+              <a:t> Panicking due to surprises</a:t>
             </a:r>
           </a:p>
         </p:txBody>
@@ -14525,8 +14573,14 @@
           </a:bodyPr>
           <a:lstStyle/>
           <a:p>
-            <a:r>
-              <a:t>Imagen</a:t>
+            <a:pPr marL="0" indent="0">
+              <a:buNone/>
+            </a:pPr>
+            <a:r>
+              <a:rPr lang="en-US" dirty="0">
+                <a:cs typeface="Calibri"/>
+              </a:rPr>
+              <a:t>Picture</a:t>
             </a:r>
           </a:p>
         </p:txBody>
@@ -14595,7 +14649,9 @@
             <a:spAutoFit/>
           </a:bodyPr>
           <a:lstStyle/>
-          <a:p/>
+          <a:p>
+            <a:endParaRPr lang="en-US"/>
+          </a:p>
         </p:txBody>
       </p:sp>
       <p:pic>
@@ -14697,8 +14753,12 @@
           <a:lstStyle/>
           <a:p>
             <a:r>
-              <a:t>¿Cuáles son algunas formas de mejorar una presentación de PowerPoint?</a:t>
-            </a:r>
+              <a:rPr lang="en-US" dirty="0">
+                <a:cs typeface="Calibri Light"/>
+              </a:rPr>
+              <a:t>What are some ways of improving a PowerPoint presentation?</a:t>
+            </a:r>
+            <a:endParaRPr lang="en-US" dirty="0"/>
           </a:p>
         </p:txBody>
       </p:sp>
@@ -14726,27 +14786,42 @@
           <a:lstStyle/>
           <a:p>
             <a:r>
-              <a:t>diapositivas simples </a:t>
-            </a:r>
-          </a:p>
-          <a:p>
-            <a:r>
-              <a:t>Efectos mínimos</a:t>
-            </a:r>
-          </a:p>
-          <a:p>
-            <a:r>
-              <a:t>Listas en lugar de líneas</a:t>
-            </a:r>
-          </a:p>
-          <a:p>
-            <a:r>
-              <a:t>Frases sobre oraciones</a:t>
-            </a:r>
-          </a:p>
-          <a:p>
-            <a:r>
-              <a:t>Una idea por diapositiva</a:t>
+              <a:rPr lang="en-US" dirty="0">
+                <a:cs typeface="Calibri"/>
+              </a:rPr>
+              <a:t>Simple slides </a:t>
+            </a:r>
+          </a:p>
+          <a:p>
+            <a:r>
+              <a:rPr lang="en-US" dirty="0">
+                <a:cs typeface="Calibri"/>
+              </a:rPr>
+              <a:t>Minimal Effects</a:t>
+            </a:r>
+          </a:p>
+          <a:p>
+            <a:r>
+              <a:rPr lang="en-US" dirty="0">
+                <a:cs typeface="Calibri"/>
+              </a:rPr>
+              <a:t>Lists instead of lines</a:t>
+            </a:r>
+          </a:p>
+          <a:p>
+            <a:r>
+              <a:rPr lang="en-US" dirty="0">
+                <a:cs typeface="Calibri"/>
+              </a:rPr>
+              <a:t>Phrases over sentences</a:t>
+            </a:r>
+          </a:p>
+          <a:p>
+            <a:r>
+              <a:rPr lang="en-US" dirty="0">
+                <a:cs typeface="Calibri"/>
+              </a:rPr>
+              <a:t>One idea per slide</a:t>
             </a:r>
           </a:p>
         </p:txBody>
@@ -14774,8 +14849,14 @@
           </a:bodyPr>
           <a:lstStyle/>
           <a:p>
-            <a:r>
-              <a:t>Imagen</a:t>
+            <a:pPr marL="0" indent="0">
+              <a:buNone/>
+            </a:pPr>
+            <a:r>
+              <a:rPr lang="en-US" dirty="0">
+                <a:cs typeface="Calibri"/>
+              </a:rPr>
+              <a:t>Picture</a:t>
             </a:r>
           </a:p>
         </p:txBody>
@@ -14844,7 +14925,9 @@
             <a:spAutoFit/>
           </a:bodyPr>
           <a:lstStyle/>
-          <a:p/>
+          <a:p>
+            <a:endParaRPr lang="en-US"/>
+          </a:p>
         </p:txBody>
       </p:sp>
       <p:pic>
@@ -14933,8 +15016,12 @@
           <a:lstStyle/>
           <a:p>
             <a:r>
-              <a:t>¿Cuál es la mejor manera de realizar una presentación?</a:t>
-            </a:r>
+              <a:rPr lang="en-US" dirty="0">
+                <a:cs typeface="Calibri Light"/>
+              </a:rPr>
+              <a:t>How do you best deliver a presentation?</a:t>
+            </a:r>
+            <a:endParaRPr lang="en-US" dirty="0"/>
           </a:p>
         </p:txBody>
       </p:sp>
@@ -14962,27 +15049,42 @@
           <a:lstStyle/>
           <a:p>
             <a:r>
-              <a:t>Gancho de apertura</a:t>
-            </a:r>
-          </a:p>
-          <a:p>
-            <a:r>
-              <a:t>Proyectar claramente</a:t>
-            </a:r>
-          </a:p>
-          <a:p>
-            <a:r>
-              <a:t>Pausa para recuperar el enfoque</a:t>
-            </a:r>
-          </a:p>
-          <a:p>
-            <a:r>
-              <a:t>Emoción y tono variado.</a:t>
-            </a:r>
-          </a:p>
-          <a:p>
-            <a:r>
-              <a:t>contacto visual</a:t>
+              <a:rPr lang="en-US" dirty="0">
+                <a:cs typeface="Calibri"/>
+              </a:rPr>
+              <a:t>Opening hook</a:t>
+            </a:r>
+          </a:p>
+          <a:p>
+            <a:r>
+              <a:rPr lang="en-US" dirty="0">
+                <a:cs typeface="Calibri"/>
+              </a:rPr>
+              <a:t>Project clearly</a:t>
+            </a:r>
+          </a:p>
+          <a:p>
+            <a:r>
+              <a:rPr lang="en-US" dirty="0">
+                <a:cs typeface="Calibri"/>
+              </a:rPr>
+              <a:t>Pause to regain focus</a:t>
+            </a:r>
+          </a:p>
+          <a:p>
+            <a:r>
+              <a:rPr lang="en-US" dirty="0">
+                <a:cs typeface="Calibri"/>
+              </a:rPr>
+              <a:t>Emotion and varied tone</a:t>
+            </a:r>
+          </a:p>
+          <a:p>
+            <a:r>
+              <a:rPr lang="en-US" dirty="0">
+                <a:cs typeface="Calibri"/>
+              </a:rPr>
+              <a:t>Eye contact</a:t>
             </a:r>
           </a:p>
         </p:txBody>
@@ -15010,8 +15112,14 @@
           </a:bodyPr>
           <a:lstStyle/>
           <a:p>
-            <a:r>
-              <a:t>Imagen</a:t>
+            <a:pPr marL="0" indent="0">
+              <a:buNone/>
+            </a:pPr>
+            <a:r>
+              <a:rPr lang="en-US" dirty="0">
+                <a:cs typeface="Calibri"/>
+              </a:rPr>
+              <a:t>Picture</a:t>
             </a:r>
           </a:p>
         </p:txBody>
@@ -15080,7 +15188,9 @@
             <a:spAutoFit/>
           </a:bodyPr>
           <a:lstStyle/>
-          <a:p/>
+          <a:p>
+            <a:endParaRPr lang="en-US"/>
+          </a:p>
         </p:txBody>
       </p:sp>
       <p:pic>
@@ -15187,8 +15297,12 @@
           <a:lstStyle/>
           <a:p>
             <a:r>
-              <a:t>Preguntas</a:t>
-            </a:r>
+              <a:rPr lang="en-US" dirty="0">
+                <a:cs typeface="Calibri Light"/>
+              </a:rPr>
+              <a:t>Questions </a:t>
+            </a:r>
+            <a:endParaRPr lang="en-US" dirty="0"/>
           </a:p>
         </p:txBody>
       </p:sp>
@@ -15215,8 +15329,14 @@
           </a:bodyPr>
           <a:lstStyle/>
           <a:p>
-            <a:r>
-              <a:t>Imagen</a:t>
+            <a:pPr marL="0" indent="0">
+              <a:buNone/>
+            </a:pPr>
+            <a:r>
+              <a:rPr lang="en-US" dirty="0">
+                <a:cs typeface="Calibri"/>
+              </a:rPr>
+              <a:t>Picture</a:t>
             </a:r>
           </a:p>
         </p:txBody>
@@ -15285,7 +15405,9 @@
             <a:spAutoFit/>
           </a:bodyPr>
           <a:lstStyle/>
-          <a:p/>
+          <a:p>
+            <a:endParaRPr lang="en-US"/>
+          </a:p>
         </p:txBody>
       </p:sp>
       <p:pic>
@@ -15387,8 +15509,12 @@
           <a:lstStyle/>
           <a:p>
             <a:r>
-              <a:t>Referencias</a:t>
-            </a:r>
+              <a:rPr lang="en-US" dirty="0">
+                <a:cs typeface="Calibri Light"/>
+              </a:rPr>
+              <a:t>References </a:t>
+            </a:r>
+            <a:endParaRPr lang="en-US" dirty="0"/>
           </a:p>
         </p:txBody>
       </p:sp>
@@ -15416,63 +15542,299 @@
           <a:lstStyle/>
           <a:p>
             <a:r>
-              <a:t>https://support.microsoft.com/en-us/office/basic-tasks-for-creating-a-powerpoint-presentation-efbbc1cd-c5f1-4264-b48e-c8a7b0334e36</a:t>
-            </a:r>
-          </a:p>
-          <a:p>
-            <a:r>
-              <a:t>https://www.beautiful.ai/blog/6-diferentes-tipos-de-presentaciones</a:t>
-            </a:r>
-          </a:p>
-          <a:p>
-            <a:r>
-              <a:t>https://outu.be/S5c1susCPAE</a:t>
-            </a:r>
-          </a:p>
-          <a:p>
-            <a:r>
-              <a:t>https://www.glassdoor.com/blog/presentation-mistakes/</a:t>
-            </a:r>
-          </a:p>
-          <a:p>
-            <a:r>
-              <a:t>https://slidepeak.com/blog/50-tips-on-how-to-improve-powerpoint-presentations-in-2021</a:t>
-            </a:r>
-          </a:p>
-          <a:p>
-            <a:r>
-              <a:t>https://www.petersons.com/blog/11-tips-for-delivering-an- Effective-presentation/</a:t>
-            </a:r>
-          </a:p>
-          <a:p>
-            <a:r>
-              <a:t>https://venngage-wordpress.s3.amazonaws.com/uploads/2019/02/template-texture.png</a:t>
-            </a:r>
-          </a:p>
-          <a:p>
-            <a:r>
-              <a:t>https://about.imginators.com/wp-content/uploads/2018/06/introduction-to-business-presentation.png</a:t>
-            </a:r>
-          </a:p>
-          <a:p>
-            <a:r>
-              <a:t>https://s39939.pcdn.co/wp-content/uploads/2017/06/Bad_Powerpoint_Slide-1.jpg</a:t>
-            </a:r>
-          </a:p>
-          <a:p>
-            <a:r>
+              <a:rPr lang="en-US" dirty="0">
+                <a:cs typeface="Calibri"/>
+              </a:rPr>
+              <a:t>https://</a:t>
+            </a:r>
+            <a:r>
+              <a:rPr lang="en-US" dirty="0" err="1">
+                <a:cs typeface="Calibri"/>
+              </a:rPr>
+              <a:t>support.microsoft.com</a:t>
+            </a:r>
+            <a:r>
+              <a:rPr lang="en-US" dirty="0">
+                <a:cs typeface="Calibri"/>
+              </a:rPr>
+              <a:t>/</a:t>
+            </a:r>
+            <a:r>
+              <a:rPr lang="en-US" dirty="0" err="1">
+                <a:cs typeface="Calibri"/>
+              </a:rPr>
+              <a:t>en</a:t>
+            </a:r>
+            <a:r>
+              <a:rPr lang="en-US" dirty="0">
+                <a:cs typeface="Calibri"/>
+              </a:rPr>
+              <a:t>-us/office/basic-tasks-for-creating-a-powerpoint-presentation-efbbc1cd-c5f1-4264-b48e-c8a7b0334e36</a:t>
+            </a:r>
+          </a:p>
+          <a:p>
+            <a:r>
+              <a:rPr lang="en-US" dirty="0">
+                <a:cs typeface="Calibri"/>
+              </a:rPr>
+              <a:t>https://</a:t>
+            </a:r>
+            <a:r>
+              <a:rPr lang="en-US" dirty="0" err="1">
+                <a:cs typeface="Calibri"/>
+              </a:rPr>
+              <a:t>www.beautiful.ai</a:t>
+            </a:r>
+            <a:r>
+              <a:rPr lang="en-US" dirty="0">
+                <a:cs typeface="Calibri"/>
+              </a:rPr>
+              <a:t>/blog/6-different-types-of-presentations</a:t>
+            </a:r>
+          </a:p>
+          <a:p>
+            <a:r>
+              <a:rPr lang="en-US" dirty="0">
+                <a:cs typeface="Calibri"/>
+              </a:rPr>
+              <a:t>https://</a:t>
+            </a:r>
+            <a:r>
+              <a:rPr lang="en-US" dirty="0" err="1">
+                <a:cs typeface="Calibri"/>
+              </a:rPr>
+              <a:t>outu.be</a:t>
+            </a:r>
+            <a:r>
+              <a:rPr lang="en-US" dirty="0">
+                <a:cs typeface="Calibri"/>
+              </a:rPr>
+              <a:t>/S5c1susCPAE</a:t>
+            </a:r>
+          </a:p>
+          <a:p>
+            <a:r>
+              <a:rPr lang="en-US" dirty="0">
+                <a:cs typeface="Calibri"/>
+              </a:rPr>
+              <a:t>https://</a:t>
+            </a:r>
+            <a:r>
+              <a:rPr lang="en-US" dirty="0" err="1">
+                <a:cs typeface="Calibri"/>
+              </a:rPr>
+              <a:t>www.glassdoor.com</a:t>
+            </a:r>
+            <a:r>
+              <a:rPr lang="en-US" dirty="0">
+                <a:cs typeface="Calibri"/>
+              </a:rPr>
+              <a:t>/blog/presentation-mistakes/</a:t>
+            </a:r>
+          </a:p>
+          <a:p>
+            <a:r>
+              <a:rPr lang="en-US" dirty="0">
+                <a:cs typeface="Calibri"/>
+              </a:rPr>
+              <a:t>https://</a:t>
+            </a:r>
+            <a:r>
+              <a:rPr lang="en-US" dirty="0" err="1">
+                <a:cs typeface="Calibri"/>
+              </a:rPr>
+              <a:t>slidepeak.com</a:t>
+            </a:r>
+            <a:r>
+              <a:rPr lang="en-US" dirty="0">
+                <a:cs typeface="Calibri"/>
+              </a:rPr>
+              <a:t>/blog/50-tips-on-how-to-improve-powerpoint-presentations-in-2021</a:t>
+            </a:r>
+          </a:p>
+          <a:p>
+            <a:r>
+              <a:rPr lang="en-US" dirty="0">
+                <a:cs typeface="Calibri"/>
+              </a:rPr>
+              <a:t>https://</a:t>
+            </a:r>
+            <a:r>
+              <a:rPr lang="en-US" dirty="0" err="1">
+                <a:cs typeface="Calibri"/>
+              </a:rPr>
+              <a:t>www.petersons.com</a:t>
+            </a:r>
+            <a:r>
+              <a:rPr lang="en-US" dirty="0">
+                <a:cs typeface="Calibri"/>
+              </a:rPr>
+              <a:t>/blog/11-tips-for-delivering-an-effective-presentation/</a:t>
+            </a:r>
+          </a:p>
+          <a:p>
+            <a:r>
+              <a:rPr lang="en-US" dirty="0">
+                <a:cs typeface="Calibri"/>
+              </a:rPr>
+              <a:t>https://venngage-wordpress.s3.amazonaws.com/uploads/2019/02/template-</a:t>
+            </a:r>
+            <a:r>
+              <a:rPr lang="en-US" dirty="0" err="1">
+                <a:cs typeface="Calibri"/>
+              </a:rPr>
+              <a:t>texture.png</a:t>
+            </a:r>
+            <a:endParaRPr lang="en-US" dirty="0">
+              <a:cs typeface="Calibri"/>
+            </a:endParaRPr>
+          </a:p>
+          <a:p>
+            <a:r>
+              <a:rPr lang="en-US" dirty="0">
+                <a:cs typeface="Calibri"/>
+              </a:rPr>
+              <a:t>https://</a:t>
+            </a:r>
+            <a:r>
+              <a:rPr lang="en-US" dirty="0" err="1">
+                <a:cs typeface="Calibri"/>
+              </a:rPr>
+              <a:t>about.imginators.com</a:t>
+            </a:r>
+            <a:r>
+              <a:rPr lang="en-US" dirty="0">
+                <a:cs typeface="Calibri"/>
+              </a:rPr>
+              <a:t>/</a:t>
+            </a:r>
+            <a:r>
+              <a:rPr lang="en-US" dirty="0" err="1">
+                <a:cs typeface="Calibri"/>
+              </a:rPr>
+              <a:t>wp</a:t>
+            </a:r>
+            <a:r>
+              <a:rPr lang="en-US" dirty="0">
+                <a:cs typeface="Calibri"/>
+              </a:rPr>
+              <a:t>-content/uploads/2018/06/introduction-to-business-</a:t>
+            </a:r>
+            <a:r>
+              <a:rPr lang="en-US" dirty="0" err="1">
+                <a:cs typeface="Calibri"/>
+              </a:rPr>
+              <a:t>presentation.png</a:t>
+            </a:r>
+            <a:endParaRPr lang="en-US" dirty="0">
+              <a:cs typeface="Calibri"/>
+            </a:endParaRPr>
+          </a:p>
+          <a:p>
+            <a:r>
+              <a:rPr lang="en-US" dirty="0">
+                <a:cs typeface="Calibri"/>
+              </a:rPr>
+              <a:t>https://s39939.pcdn.co/</a:t>
+            </a:r>
+            <a:r>
+              <a:rPr lang="en-US" dirty="0" err="1">
+                <a:cs typeface="Calibri"/>
+              </a:rPr>
+              <a:t>wp</a:t>
+            </a:r>
+            <a:r>
+              <a:rPr lang="en-US" dirty="0">
+                <a:cs typeface="Calibri"/>
+              </a:rPr>
+              <a:t>-content/uploads/2017/06/Bad_Powerpoint_Slide-1.jpg</a:t>
+            </a:r>
+          </a:p>
+          <a:p>
+            <a:r>
+              <a:rPr lang="en-US" dirty="0">
+                <a:cs typeface="Calibri"/>
+              </a:rPr>
               <a:t> https://adriennejohnston.com/wp-content/webpc-passthru.php?src=https://adriennejohnston.com/wp-content/uploads/2019/08/PowerPoint-Expert-Tips-no-bullets-768x435.png&amp;nocache=1</a:t>
             </a:r>
           </a:p>
           <a:p>
             <a:r>
-              <a:t>https://simplyamazingtraining.co.uk/wp-content/uploads/2020/01/dont-forget-to-breath-banner-resized-1-730x411.png</a:t>
-            </a:r>
-          </a:p>
-          <a:p>
-            <a:r>
-              <a:t>https://virtualspeech.com/img/blog/header/importance_eye_contact_presentation.jpg</a:t>
-            </a:r>
+              <a:rPr lang="en-US" dirty="0">
+                <a:cs typeface="Calibri"/>
+              </a:rPr>
+              <a:t>https://</a:t>
+            </a:r>
+            <a:r>
+              <a:rPr lang="en-US" dirty="0" err="1">
+                <a:cs typeface="Calibri"/>
+              </a:rPr>
+              <a:t>simplyamazingtraining.co.uk</a:t>
+            </a:r>
+            <a:r>
+              <a:rPr lang="en-US" dirty="0">
+                <a:cs typeface="Calibri"/>
+              </a:rPr>
+              <a:t>/</a:t>
+            </a:r>
+            <a:r>
+              <a:rPr lang="en-US" dirty="0" err="1">
+                <a:cs typeface="Calibri"/>
+              </a:rPr>
+              <a:t>wp</a:t>
+            </a:r>
+            <a:r>
+              <a:rPr lang="en-US" dirty="0">
+                <a:cs typeface="Calibri"/>
+              </a:rPr>
+              <a:t>-content/uploads/2020/01/dont-forget-to-breath-banner-resized-1-730x411.png</a:t>
+            </a:r>
+          </a:p>
+          <a:p>
+            <a:r>
+              <a:rPr lang="en-US" dirty="0">
+                <a:cs typeface="Calibri"/>
+              </a:rPr>
+              <a:t>https://</a:t>
+            </a:r>
+            <a:r>
+              <a:rPr lang="en-US" dirty="0" err="1">
+                <a:cs typeface="Calibri"/>
+              </a:rPr>
+              <a:t>virtualspeech.com</a:t>
+            </a:r>
+            <a:r>
+              <a:rPr lang="en-US" dirty="0">
+                <a:cs typeface="Calibri"/>
+              </a:rPr>
+              <a:t>/</a:t>
+            </a:r>
+            <a:r>
+              <a:rPr lang="en-US" dirty="0" err="1">
+                <a:cs typeface="Calibri"/>
+              </a:rPr>
+              <a:t>img</a:t>
+            </a:r>
+            <a:r>
+              <a:rPr lang="en-US" dirty="0">
+                <a:cs typeface="Calibri"/>
+              </a:rPr>
+              <a:t>/blog/header/</a:t>
+            </a:r>
+            <a:r>
+              <a:rPr lang="en-US" dirty="0" err="1">
+                <a:cs typeface="Calibri"/>
+              </a:rPr>
+              <a:t>importance_eye_contact_presentation.jpg</a:t>
+            </a:r>
+            <a:endParaRPr lang="en-US" dirty="0">
+              <a:cs typeface="Calibri"/>
+            </a:endParaRPr>
+          </a:p>
+          <a:p>
+            <a:endParaRPr lang="en-US" dirty="0">
+              <a:cs typeface="Calibri"/>
+            </a:endParaRPr>
           </a:p>
         </p:txBody>
       </p:sp>

</xml_diff>

<commit_message>
Added comments to GUI and made GUI progress clearer.
</commit_message>
<xml_diff>
--- a/results/Making a Presentation Presentation Spanish.pptx
+++ b/results/Making a Presentation Presentation Spanish.pptx
@@ -13667,8 +13667,12 @@
           <a:lstStyle/>
           <a:p>
             <a:r>
-              <a:t>Por CJ Conti</a:t>
-            </a:r>
+              <a:rPr lang="en-US" dirty="0">
+                <a:cs typeface="Calibri"/>
+              </a:rPr>
+              <a:t>By CJ Conti</a:t>
+            </a:r>
+            <a:endParaRPr lang="en-US" dirty="0"/>
           </a:p>
         </p:txBody>
       </p:sp>
@@ -13724,8 +13728,12 @@
           <a:lstStyle/>
           <a:p>
             <a:r>
-              <a:t>¿Qué es una presentación de PowerPoint?</a:t>
-            </a:r>
+              <a:rPr lang="en-US" dirty="0">
+                <a:cs typeface="Calibri Light"/>
+              </a:rPr>
+              <a:t>What is a PowerPoint Presentation</a:t>
+            </a:r>
+            <a:endParaRPr lang="en-US" dirty="0"/>
           </a:p>
         </p:txBody>
       </p:sp>
@@ -13753,22 +13761,34 @@
           <a:lstStyle/>
           <a:p>
             <a:r>
-              <a:t>Serie de diapositivas</a:t>
-            </a:r>
-          </a:p>
-          <a:p>
-            <a:r>
-              <a:t>Imágenes de texto y vídeos.</a:t>
-            </a:r>
-          </a:p>
-          <a:p>
-            <a:r>
-              <a:t>“Transmitir un mensaje o una historia” </a:t>
-            </a:r>
-          </a:p>
-          <a:p>
-            <a:r>
-              <a:t>Consulta siempre el mensaje o la historia.</a:t>
+              <a:rPr lang="en-US" dirty="0">
+                <a:cs typeface="Calibri"/>
+              </a:rPr>
+              <a:t>Series of slides</a:t>
+            </a:r>
+          </a:p>
+          <a:p>
+            <a:r>
+              <a:rPr lang="en-US" dirty="0">
+                <a:cs typeface="Calibri"/>
+              </a:rPr>
+              <a:t>Text images and videos</a:t>
+            </a:r>
+          </a:p>
+          <a:p>
+            <a:r>
+              <a:rPr lang="en-US" dirty="0">
+                <a:cs typeface="Calibri"/>
+              </a:rPr>
+              <a:t>“Convey a message or story” </a:t>
+            </a:r>
+          </a:p>
+          <a:p>
+            <a:r>
+              <a:rPr lang="en-US" dirty="0">
+                <a:cs typeface="Calibri"/>
+              </a:rPr>
+              <a:t>Always refer back to message/story</a:t>
             </a:r>
           </a:p>
         </p:txBody>
@@ -13837,7 +13857,9 @@
             <a:spAutoFit/>
           </a:bodyPr>
           <a:lstStyle/>
-          <a:p/>
+          <a:p>
+            <a:endParaRPr lang="en-US"/>
+          </a:p>
         </p:txBody>
       </p:sp>
       <p:pic>

</xml_diff>